<commit_message>
Corregir la Figura 1 y declarar el techo fisiologico de PA y los dos modelos de IA
La Figura 1 decia "28 lecturas invertidas anuladas" (cifra de v1.1; hoy son 0) y el
Metodos no declaraba el techo 270/180 que el codigo aplica. La declaracion de IA omitia
el cambio de Opus 5 a Sonnet 5 del 20 de agosto.

Co-Authored-By: Claude Sonnet 5 <noreply@anthropic.com>
</commit_message>
<xml_diff>
--- a/FIGURAS/Fig1_flujo_STROBE.pptx
+++ b/FIGURAS/Fig1_flujo_STROBE.pptx
@@ -2667,7 +2667,7 @@
           </p:nvSpPr>
           <p:spPr>
             <a:xfrm>
-              <a:off x="1668608" y="2034254"/>
+              <a:off x="1668608" y="2096695"/>
               <a:ext cx="1050554" cy="82661"/>
             </a:xfrm>
             <a:prstGeom prst="rect">
@@ -2710,8 +2710,8 @@
           </p:nvSpPr>
           <p:spPr>
             <a:xfrm>
-              <a:off x="1523127" y="2159136"/>
-              <a:ext cx="1341516" cy="82661"/>
+              <a:off x="1320131" y="2221578"/>
+              <a:ext cx="1747509" cy="82661"/>
             </a:xfrm>
             <a:prstGeom prst="rect">
               <a:avLst/>
@@ -2740,7 +2740,7 @@
                   <a:latin typeface="Arial"/>
                   <a:cs typeface="Arial"/>
                 </a:rPr>
-                <a:t>(PAS≥80, PAD≥50 mmHg;</a:t>
+                <a:t>(PAS 80-270, PAD 50-180 mmHg)</a:t>
               </a:r>
             </a:p>
           </p:txBody>
@@ -2753,50 +2753,7 @@
           </p:nvSpPr>
           <p:spPr>
             <a:xfrm>
-              <a:off x="1378606" y="2284019"/>
-              <a:ext cx="1630558" cy="82661"/>
-            </a:xfrm>
-            <a:prstGeom prst="rect">
-              <a:avLst/>
-            </a:prstGeom>
-            <a:noFill/>
-          </p:spPr>
-          <p:txBody>
-            <a:bodyPr lIns="0" rIns="0" tIns="0" bIns="0" anchorCtr="1" anchor="ctr" wrap="none"/>
-            <a:lstStyle/>
-            <a:p>
-              <a:pPr algn="l" marL="0" marR="0" indent="0">
-                <a:spcBef>
-                  <a:spcPts val="0"/>
-                </a:spcBef>
-                <a:spcAft>
-                  <a:spcPts val="0"/>
-                </a:spcAft>
-              </a:pPr>
-              <a:r>
-                <a:rPr sz="910" i="0" b="0">
-                  <a:solidFill>
-                    <a:srgbClr val="000000">
-                      <a:alpha val="100000"/>
-                    </a:srgbClr>
-                  </a:solidFill>
-                  <a:latin typeface="Arial"/>
-                  <a:cs typeface="Arial"/>
-                </a:rPr>
-                <a:t>28 lecturas invertidas anuladas)</a:t>
-              </a:r>
-            </a:p>
-          </p:txBody>
-        </p:sp>
-        <p:sp>
-          <p:nvSpPr>
-            <p:cNvPr id="18" name="tx18"/>
-            <p:cNvSpPr/>
-            <p:nvPr/>
-          </p:nvSpPr>
-          <p:spPr>
-            <a:xfrm>
-              <a:off x="1919428" y="2408902"/>
+              <a:off x="1919428" y="2346460"/>
               <a:ext cx="548914" cy="82661"/>
             </a:xfrm>
             <a:prstGeom prst="rect">
@@ -2833,7 +2790,7 @@
         </p:sp>
         <p:sp>
           <p:nvSpPr>
-            <p:cNvPr id="19" name="tx19"/>
+            <p:cNvPr id="18" name="tx18"/>
             <p:cNvSpPr/>
             <p:nvPr/>
           </p:nvSpPr>
@@ -2876,7 +2833,7 @@
         </p:sp>
         <p:sp>
           <p:nvSpPr>
-            <p:cNvPr id="20" name="tx20"/>
+            <p:cNvPr id="19" name="tx19"/>
             <p:cNvSpPr/>
             <p:nvPr/>
           </p:nvSpPr>
@@ -2919,7 +2876,7 @@
         </p:sp>
         <p:sp>
           <p:nvSpPr>
-            <p:cNvPr id="21" name="tx21"/>
+            <p:cNvPr id="20" name="tx20"/>
             <p:cNvSpPr/>
             <p:nvPr/>
           </p:nvSpPr>
@@ -2962,7 +2919,7 @@
         </p:sp>
         <p:sp>
           <p:nvSpPr>
-            <p:cNvPr id="22" name="tx22"/>
+            <p:cNvPr id="21" name="tx21"/>
             <p:cNvSpPr/>
             <p:nvPr/>
           </p:nvSpPr>
@@ -3005,7 +2962,7 @@
         </p:sp>
         <p:sp>
           <p:nvSpPr>
-            <p:cNvPr id="23" name="tx23"/>
+            <p:cNvPr id="22" name="tx22"/>
             <p:cNvSpPr/>
             <p:nvPr/>
           </p:nvSpPr>
@@ -3048,7 +3005,7 @@
         </p:sp>
         <p:sp>
           <p:nvSpPr>
-            <p:cNvPr id="24" name="tx24"/>
+            <p:cNvPr id="23" name="tx23"/>
             <p:cNvSpPr/>
             <p:nvPr/>
           </p:nvSpPr>
@@ -3091,7 +3048,7 @@
         </p:sp>
         <p:sp>
           <p:nvSpPr>
-            <p:cNvPr id="25" name="tx25"/>
+            <p:cNvPr id="24" name="tx24"/>
             <p:cNvSpPr/>
             <p:nvPr/>
           </p:nvSpPr>
@@ -3134,7 +3091,7 @@
         </p:sp>
         <p:sp>
           <p:nvSpPr>
-            <p:cNvPr id="26" name="tx26"/>
+            <p:cNvPr id="25" name="tx25"/>
             <p:cNvSpPr/>
             <p:nvPr/>
           </p:nvSpPr>
@@ -3177,7 +3134,7 @@
         </p:sp>
         <p:sp>
           <p:nvSpPr>
-            <p:cNvPr id="27" name="tx27"/>
+            <p:cNvPr id="26" name="tx26"/>
             <p:cNvSpPr/>
             <p:nvPr/>
           </p:nvSpPr>
@@ -3220,7 +3177,7 @@
         </p:sp>
         <p:sp>
           <p:nvSpPr>
-            <p:cNvPr id="28" name="tx28"/>
+            <p:cNvPr id="27" name="tx27"/>
             <p:cNvSpPr/>
             <p:nvPr/>
           </p:nvSpPr>
@@ -3263,7 +3220,7 @@
         </p:sp>
         <p:sp>
           <p:nvSpPr>
-            <p:cNvPr id="29" name="tx29"/>
+            <p:cNvPr id="28" name="tx28"/>
             <p:cNvSpPr/>
             <p:nvPr/>
           </p:nvSpPr>
@@ -3306,7 +3263,7 @@
         </p:sp>
         <p:sp>
           <p:nvSpPr>
-            <p:cNvPr id="30" name="tx30"/>
+            <p:cNvPr id="29" name="tx29"/>
             <p:cNvSpPr/>
             <p:nvPr/>
           </p:nvSpPr>
@@ -3349,7 +3306,7 @@
         </p:sp>
         <p:sp>
           <p:nvSpPr>
-            <p:cNvPr id="31" name="tx31"/>
+            <p:cNvPr id="30" name="tx30"/>
             <p:cNvSpPr/>
             <p:nvPr/>
           </p:nvSpPr>
@@ -3392,7 +3349,7 @@
         </p:sp>
         <p:sp>
           <p:nvSpPr>
-            <p:cNvPr id="32" name="pl32"/>
+            <p:cNvPr id="31" name="pl31"/>
             <p:cNvSpPr/>
             <p:nvPr/>
           </p:nvSpPr>
@@ -3432,7 +3389,7 @@
         </p:sp>
         <p:sp>
           <p:nvSpPr>
-            <p:cNvPr id="33" name="pl33"/>
+            <p:cNvPr id="32" name="pl32"/>
             <p:cNvSpPr/>
             <p:nvPr/>
           </p:nvSpPr>
@@ -3475,7 +3432,7 @@
         </p:sp>
         <p:sp>
           <p:nvSpPr>
-            <p:cNvPr id="34" name="pl34"/>
+            <p:cNvPr id="33" name="pl33"/>
             <p:cNvSpPr/>
             <p:nvPr/>
           </p:nvSpPr>
@@ -3515,7 +3472,7 @@
         </p:sp>
         <p:sp>
           <p:nvSpPr>
-            <p:cNvPr id="35" name="pl35"/>
+            <p:cNvPr id="34" name="pl34"/>
             <p:cNvSpPr/>
             <p:nvPr/>
           </p:nvSpPr>
@@ -3558,7 +3515,7 @@
         </p:sp>
         <p:sp>
           <p:nvSpPr>
-            <p:cNvPr id="36" name="pl36"/>
+            <p:cNvPr id="35" name="pl35"/>
             <p:cNvSpPr/>
             <p:nvPr/>
           </p:nvSpPr>
@@ -3598,7 +3555,7 @@
         </p:sp>
         <p:sp>
           <p:nvSpPr>
-            <p:cNvPr id="37" name="pl37"/>
+            <p:cNvPr id="36" name="pl36"/>
             <p:cNvSpPr/>
             <p:nvPr/>
           </p:nvSpPr>
@@ -3641,7 +3598,7 @@
         </p:sp>
         <p:sp>
           <p:nvSpPr>
-            <p:cNvPr id="38" name="pl38"/>
+            <p:cNvPr id="37" name="pl37"/>
             <p:cNvSpPr/>
             <p:nvPr/>
           </p:nvSpPr>
@@ -3681,7 +3638,7 @@
         </p:sp>
         <p:sp>
           <p:nvSpPr>
-            <p:cNvPr id="39" name="pl39"/>
+            <p:cNvPr id="38" name="pl38"/>
             <p:cNvSpPr/>
             <p:nvPr/>
           </p:nvSpPr>
@@ -3724,7 +3681,7 @@
         </p:sp>
         <p:sp>
           <p:nvSpPr>
-            <p:cNvPr id="40" name="pl40"/>
+            <p:cNvPr id="39" name="pl39"/>
             <p:cNvSpPr/>
             <p:nvPr/>
           </p:nvSpPr>
@@ -3764,7 +3721,7 @@
         </p:sp>
         <p:sp>
           <p:nvSpPr>
-            <p:cNvPr id="41" name="pl41"/>
+            <p:cNvPr id="40" name="pl40"/>
             <p:cNvSpPr/>
             <p:nvPr/>
           </p:nvSpPr>
@@ -3807,7 +3764,7 @@
         </p:sp>
         <p:sp>
           <p:nvSpPr>
-            <p:cNvPr id="42" name="pl42"/>
+            <p:cNvPr id="41" name="pl41"/>
             <p:cNvSpPr/>
             <p:nvPr/>
           </p:nvSpPr>
@@ -3847,7 +3804,7 @@
         </p:sp>
         <p:sp>
           <p:nvSpPr>
-            <p:cNvPr id="43" name="pl43"/>
+            <p:cNvPr id="42" name="pl42"/>
             <p:cNvSpPr/>
             <p:nvPr/>
           </p:nvSpPr>
@@ -3890,7 +3847,7 @@
         </p:sp>
         <p:sp>
           <p:nvSpPr>
-            <p:cNvPr id="44" name="pl44"/>
+            <p:cNvPr id="43" name="pl43"/>
             <p:cNvSpPr/>
             <p:nvPr/>
           </p:nvSpPr>
@@ -3930,7 +3887,7 @@
         </p:sp>
         <p:sp>
           <p:nvSpPr>
-            <p:cNvPr id="45" name="pl45"/>
+            <p:cNvPr id="44" name="pl44"/>
             <p:cNvSpPr/>
             <p:nvPr/>
           </p:nvSpPr>
@@ -3970,7 +3927,7 @@
         </p:sp>
         <p:sp>
           <p:nvSpPr>
-            <p:cNvPr id="46" name="pl46"/>
+            <p:cNvPr id="45" name="pl45"/>
             <p:cNvSpPr/>
             <p:nvPr/>
           </p:nvSpPr>
@@ -4010,7 +3967,7 @@
         </p:sp>
         <p:sp>
           <p:nvSpPr>
-            <p:cNvPr id="47" name="pl47"/>
+            <p:cNvPr id="46" name="pl46"/>
             <p:cNvSpPr/>
             <p:nvPr/>
           </p:nvSpPr>
@@ -4050,7 +4007,7 @@
         </p:sp>
         <p:sp>
           <p:nvSpPr>
-            <p:cNvPr id="48" name="pl48"/>
+            <p:cNvPr id="47" name="pl47"/>
             <p:cNvSpPr/>
             <p:nvPr/>
           </p:nvSpPr>
@@ -4090,7 +4047,7 @@
         </p:sp>
         <p:sp>
           <p:nvSpPr>
-            <p:cNvPr id="49" name="rc49"/>
+            <p:cNvPr id="48" name="rc48"/>
             <p:cNvSpPr/>
             <p:nvPr/>
           </p:nvSpPr>
@@ -4125,7 +4082,7 @@
         </p:sp>
         <p:sp>
           <p:nvSpPr>
-            <p:cNvPr id="50" name="rc50"/>
+            <p:cNvPr id="49" name="rc49"/>
             <p:cNvSpPr/>
             <p:nvPr/>
           </p:nvSpPr>
@@ -4160,7 +4117,7 @@
         </p:sp>
         <p:sp>
           <p:nvSpPr>
-            <p:cNvPr id="51" name="rc51"/>
+            <p:cNvPr id="50" name="rc50"/>
             <p:cNvSpPr/>
             <p:nvPr/>
           </p:nvSpPr>
@@ -4195,7 +4152,7 @@
         </p:sp>
         <p:sp>
           <p:nvSpPr>
-            <p:cNvPr id="52" name="rc52"/>
+            <p:cNvPr id="51" name="rc51"/>
             <p:cNvSpPr/>
             <p:nvPr/>
           </p:nvSpPr>
@@ -4230,7 +4187,7 @@
         </p:sp>
         <p:sp>
           <p:nvSpPr>
-            <p:cNvPr id="53" name="rc53"/>
+            <p:cNvPr id="52" name="rc52"/>
             <p:cNvSpPr/>
             <p:nvPr/>
           </p:nvSpPr>
@@ -4265,7 +4222,7 @@
         </p:sp>
         <p:sp>
           <p:nvSpPr>
-            <p:cNvPr id="54" name="tx54"/>
+            <p:cNvPr id="53" name="tx53"/>
             <p:cNvSpPr/>
             <p:nvPr/>
           </p:nvSpPr>
@@ -4308,7 +4265,7 @@
         </p:sp>
         <p:sp>
           <p:nvSpPr>
-            <p:cNvPr id="55" name="tx55"/>
+            <p:cNvPr id="54" name="tx54"/>
             <p:cNvSpPr/>
             <p:nvPr/>
           </p:nvSpPr>
@@ -4351,7 +4308,7 @@
         </p:sp>
         <p:sp>
           <p:nvSpPr>
-            <p:cNvPr id="56" name="tx56"/>
+            <p:cNvPr id="55" name="tx55"/>
             <p:cNvSpPr/>
             <p:nvPr/>
           </p:nvSpPr>
@@ -4394,7 +4351,7 @@
         </p:sp>
         <p:sp>
           <p:nvSpPr>
-            <p:cNvPr id="57" name="tx57"/>
+            <p:cNvPr id="56" name="tx56"/>
             <p:cNvSpPr/>
             <p:nvPr/>
           </p:nvSpPr>
@@ -4437,7 +4394,7 @@
         </p:sp>
         <p:sp>
           <p:nvSpPr>
-            <p:cNvPr id="58" name="tx58"/>
+            <p:cNvPr id="57" name="tx57"/>
             <p:cNvSpPr/>
             <p:nvPr/>
           </p:nvSpPr>
@@ -4480,7 +4437,7 @@
         </p:sp>
         <p:sp>
           <p:nvSpPr>
-            <p:cNvPr id="59" name="tx59"/>
+            <p:cNvPr id="58" name="tx58"/>
             <p:cNvSpPr/>
             <p:nvPr/>
           </p:nvSpPr>
@@ -4523,7 +4480,7 @@
         </p:sp>
         <p:sp>
           <p:nvSpPr>
-            <p:cNvPr id="60" name="tx60"/>
+            <p:cNvPr id="59" name="tx59"/>
             <p:cNvSpPr/>
             <p:nvPr/>
           </p:nvSpPr>
@@ -4566,7 +4523,7 @@
         </p:sp>
         <p:sp>
           <p:nvSpPr>
-            <p:cNvPr id="61" name="tx61"/>
+            <p:cNvPr id="60" name="tx60"/>
             <p:cNvSpPr/>
             <p:nvPr/>
           </p:nvSpPr>
@@ -4609,7 +4566,7 @@
         </p:sp>
         <p:sp>
           <p:nvSpPr>
-            <p:cNvPr id="62" name="tx62"/>
+            <p:cNvPr id="61" name="tx61"/>
             <p:cNvSpPr/>
             <p:nvPr/>
           </p:nvSpPr>
@@ -4652,7 +4609,7 @@
         </p:sp>
         <p:sp>
           <p:nvSpPr>
-            <p:cNvPr id="63" name="tx63"/>
+            <p:cNvPr id="62" name="tx62"/>
             <p:cNvSpPr/>
             <p:nvPr/>
           </p:nvSpPr>

</xml_diff>